<commit_message>
feat: evolve architecture and spec lifecycle
</commit_message>
<xml_diff>
--- a/SSOT-开发方法论-培训.pptx
+++ b/SSOT-开发方法论-培训.pptx
@@ -2,28 +2,28 @@
 <file path=ppt/presentation.xml><?xml version="1.0" encoding="utf-8"?>
 <p:presentation xmlns:p="http://schemas.openxmlformats.org/presentationml/2006/main">
   <p:sldMasterIdLst>
-    <p:sldMasterId xmlns:r="http://schemas.openxmlformats.org/officeDocument/2006/relationships" id="2147483648" r:id="R6f975ce7b2a5414f"/>
+    <p:sldMasterId xmlns:r="http://schemas.openxmlformats.org/officeDocument/2006/relationships" id="2147483648" r:id="R44ec0fa5e3db4861"/>
   </p:sldMasterIdLst>
   <p:notesMasterIdLst>
-    <p:notesMasterId xmlns:r="http://schemas.openxmlformats.org/officeDocument/2006/relationships" r:id="Refddf7533f094c91"/>
+    <p:notesMasterId xmlns:r="http://schemas.openxmlformats.org/officeDocument/2006/relationships" r:id="R1c45c2b325e64d46"/>
   </p:notesMasterIdLst>
   <p:sldIdLst>
-    <p:sldId xmlns:r="http://schemas.openxmlformats.org/officeDocument/2006/relationships" id="256" r:id="R9dc03d1c9b59406a"/>
-    <p:sldId xmlns:r="http://schemas.openxmlformats.org/officeDocument/2006/relationships" id="257" r:id="Re9fdff8a91c244d8"/>
-    <p:sldId xmlns:r="http://schemas.openxmlformats.org/officeDocument/2006/relationships" id="258" r:id="Rcfbeec44f3b2484f"/>
-    <p:sldId xmlns:r="http://schemas.openxmlformats.org/officeDocument/2006/relationships" id="259" r:id="R3d7452109071454d"/>
-    <p:sldId xmlns:r="http://schemas.openxmlformats.org/officeDocument/2006/relationships" id="260" r:id="Rb36a7df39fe649eb"/>
-    <p:sldId xmlns:r="http://schemas.openxmlformats.org/officeDocument/2006/relationships" id="261" r:id="R65122c0949864bf1"/>
-    <p:sldId xmlns:r="http://schemas.openxmlformats.org/officeDocument/2006/relationships" id="262" r:id="R2b565bdef73d4aa6"/>
-    <p:sldId xmlns:r="http://schemas.openxmlformats.org/officeDocument/2006/relationships" id="263" r:id="Rf9f2b62945e34b15"/>
-    <p:sldId xmlns:r="http://schemas.openxmlformats.org/officeDocument/2006/relationships" id="264" r:id="Rce88d0d9624446d0"/>
-    <p:sldId xmlns:r="http://schemas.openxmlformats.org/officeDocument/2006/relationships" id="265" r:id="Rd5553daee5ca4003"/>
-    <p:sldId xmlns:r="http://schemas.openxmlformats.org/officeDocument/2006/relationships" id="266" r:id="Rfde22226c2c04683"/>
-    <p:sldId xmlns:r="http://schemas.openxmlformats.org/officeDocument/2006/relationships" id="267" r:id="R9f8268993bf643af"/>
-    <p:sldId xmlns:r="http://schemas.openxmlformats.org/officeDocument/2006/relationships" id="268" r:id="R30f7b189def14873"/>
-    <p:sldId xmlns:r="http://schemas.openxmlformats.org/officeDocument/2006/relationships" id="269" r:id="Rcb33476f4327427b"/>
-    <p:sldId xmlns:r="http://schemas.openxmlformats.org/officeDocument/2006/relationships" id="270" r:id="Rac8ec5ebcdc04289"/>
-    <p:sldId xmlns:r="http://schemas.openxmlformats.org/officeDocument/2006/relationships" id="271" r:id="Rf18d65f7f1614743"/>
+    <p:sldId xmlns:r="http://schemas.openxmlformats.org/officeDocument/2006/relationships" id="256" r:id="R0633c926d66b42ca"/>
+    <p:sldId xmlns:r="http://schemas.openxmlformats.org/officeDocument/2006/relationships" id="257" r:id="Rc975d4dfab7340df"/>
+    <p:sldId xmlns:r="http://schemas.openxmlformats.org/officeDocument/2006/relationships" id="258" r:id="R411ef13384cb451d"/>
+    <p:sldId xmlns:r="http://schemas.openxmlformats.org/officeDocument/2006/relationships" id="259" r:id="R0f79f9e2db074c4d"/>
+    <p:sldId xmlns:r="http://schemas.openxmlformats.org/officeDocument/2006/relationships" id="260" r:id="R9e12ad46df164046"/>
+    <p:sldId xmlns:r="http://schemas.openxmlformats.org/officeDocument/2006/relationships" id="261" r:id="Rc2ffe51397914131"/>
+    <p:sldId xmlns:r="http://schemas.openxmlformats.org/officeDocument/2006/relationships" id="262" r:id="R364dfe2bd6794924"/>
+    <p:sldId xmlns:r="http://schemas.openxmlformats.org/officeDocument/2006/relationships" id="263" r:id="R8bd7cf3f3c524aef"/>
+    <p:sldId xmlns:r="http://schemas.openxmlformats.org/officeDocument/2006/relationships" id="264" r:id="Rea97e6e9f2ed49be"/>
+    <p:sldId xmlns:r="http://schemas.openxmlformats.org/officeDocument/2006/relationships" id="265" r:id="Rc11aff910555483d"/>
+    <p:sldId xmlns:r="http://schemas.openxmlformats.org/officeDocument/2006/relationships" id="266" r:id="Rad14ec04a10943ee"/>
+    <p:sldId xmlns:r="http://schemas.openxmlformats.org/officeDocument/2006/relationships" id="267" r:id="Rcc91b38925e14700"/>
+    <p:sldId xmlns:r="http://schemas.openxmlformats.org/officeDocument/2006/relationships" id="268" r:id="Ra2af81c4ace04145"/>
+    <p:sldId xmlns:r="http://schemas.openxmlformats.org/officeDocument/2006/relationships" id="269" r:id="Rb0198d7dcc43425a"/>
+    <p:sldId xmlns:r="http://schemas.openxmlformats.org/officeDocument/2006/relationships" id="270" r:id="R2fb5c153b87447c6"/>
+    <p:sldId xmlns:r="http://schemas.openxmlformats.org/officeDocument/2006/relationships" id="271" r:id="Rb9223c65f1304df5"/>
   </p:sldIdLst>
   <p:sldSz cx="9144000" cy="5143500"/>
   <p:notesSz cx="6858000" cy="9144000"/>
@@ -1631,7 +1631,7 @@
   </p:cSld>
   <p:clrMap bg1="lt1" tx1="dk1" bg2="lt2" tx2="dk2" accent1="accent1" accent2="accent2" accent3="accent3" accent4="accent4" accent5="accent5" accent6="accent6" hlink="hlink" folHlink="folHlink"/>
   <p:sldLayoutIdLst>
-    <p:sldLayoutId xmlns:r="http://schemas.openxmlformats.org/officeDocument/2006/relationships" id="2147483649" r:id="R85fdf13d53e14911"/>
+    <p:sldLayoutId xmlns:r="http://schemas.openxmlformats.org/officeDocument/2006/relationships" id="2147483649" r:id="R6b957e759eef4d8e"/>
   </p:sldLayoutIdLst>
   <p:hf sldNum="0" hdr="0" ftr="0" dt="0"/>
   <p:txStyles>
@@ -5239,7 +5239,13 @@
       </p:sp>
       <p:graphicFrame>
         <p:nvGraphicFramePr>
-          <p:cNvPr id="19" name="Table 0"/>
+          <p:cNvPr id="19" name="Table 0">
+            <a:extLst xmlns:a="http://schemas.openxmlformats.org/drawingml/2006/main">
+              <a:ext uri="{FF2B5EF4-FFF2-40B4-BE49-F238E27FC236}">
+                <a16:creationId xmlns:a16="http://schemas.microsoft.com/office/drawing/2014/main" id="{0E2A0980-899E-40A2-A3A1-BDC8A1C0E48F}"/>
+              </a:ext>
+            </a:extLst>
+          </p:cNvPr>
           <p:cNvGraphicFramePr/>
           <p:nvPr/>
         </p:nvGraphicFramePr>
@@ -6926,7 +6932,7 @@
                 <a:ea typeface="Calibri"/>
                 <a:cs typeface="Calibri"/>
               </a:rPr>
-              <a:t>adrs/ + 审 spec + 修边界 bug</a:t>
+              <a:t>architecture/ + 必要 ADR + 审 spec</a:t>
             </a:r>
             <a:endParaRPr sz="1000"/>
           </a:p>
@@ -6972,7 +6978,7 @@
                 <a:ea typeface="Calibri"/>
                 <a:cs typeface="Calibri"/>
               </a:rPr>
-              <a:t>核心: 架构决策、方案评审</a:t>
+              <a:t>核心: 当前架构、架构决策、阶段边界</a:t>
             </a:r>
             <a:endParaRPr sz="900"/>
           </a:p>
@@ -7167,18 +7173,7 @@
                 <a:ea typeface="Calibri"/>
                 <a:cs typeface="Calibri"/>
               </a:rPr>
-              <a:t>sprints/*/specs/ 四文件</a:t>
-            </a:r>
-            <a:r>
-              <a:rPr sz="1000">
-                <a:solidFill>
-                  <a:srgbClr val="1E293B"/>
-                </a:solidFill>
-                <a:latin typeface="Calibri"/>
-                <a:ea typeface="Calibri"/>
-                <a:cs typeface="Calibri"/>
-              </a:rPr>
-              <a:t> + 按 spec 编码 + 自检</a:t>
+              <a:t>specs/ 四文件 + 按依赖顺序编码 + 自检</a:t>
             </a:r>
             <a:endParaRPr sz="1000"/>
           </a:p>
@@ -7224,7 +7219,7 @@
                 <a:ea typeface="Calibri"/>
                 <a:cs typeface="Calibri"/>
               </a:rPr>
-              <a:t>核心: 模块方案、标准化编码</a:t>
+              <a:t>核心: 等价复原、契约收口、标准编码</a:t>
             </a:r>
             <a:endParaRPr sz="900"/>
           </a:p>
@@ -9101,6 +9096,9 @@
             <a:pPr marL="0" indent="0">
               <a:buNone/>
             </a:pPr>
+            <a:r>
+              <a:t/>
+            </a:r>
             <a:endParaRPr sz="900"/>
           </a:p>
           <a:p xmlns:a="http://schemas.openxmlformats.org/drawingml/2006/main">
@@ -9116,7 +9114,7 @@
                 <a:ea typeface="Calibri"/>
                 <a:cs typeface="Calibri"/>
               </a:rPr>
-              <a:t>### spec-002 (后端认证服务)</a:t>
+              <a:t>### spec-002 → spec-004</a:t>
             </a:r>
             <a:endParaRPr sz="900"/>
           </a:p>
@@ -9150,7 +9148,24 @@
                 <a:ea typeface="Calibri"/>
                 <a:cs typeface="Calibri"/>
               </a:rPr>
-              <a:t>- GET /api/users/me</a:t>
+              <a:t>- owner: spec-004</a:t>
+            </a:r>
+            <a:endParaRPr sz="900"/>
+          </a:p>
+          <a:p xmlns:a="http://schemas.openxmlformats.org/drawingml/2006/main">
+            <a:pPr marL="0" indent="0">
+              <a:buNone/>
+            </a:pPr>
+            <a:r>
+              <a:rPr sz="900">
+                <a:solidFill>
+                  <a:srgbClr val="1E293B"/>
+                </a:solidFill>
+                <a:latin typeface="Calibri"/>
+                <a:ea typeface="Calibri"/>
+                <a:cs typeface="Calibri"/>
+              </a:rPr>
+              <a:t>- Mock = 正式契约</a:t>
             </a:r>
             <a:endParaRPr sz="900"/>
           </a:p>
@@ -9267,7 +9282,7 @@
                 <a:ea typeface="Calibri"/>
                 <a:cs typeface="Calibri"/>
               </a:rPr>
-              <a:t>拆层验证法</a:t>
+              <a:t>阶段收口检查</a:t>
             </a:r>
             <a:endParaRPr sz="1100"/>
           </a:p>
@@ -9313,7 +9328,7 @@
                 <a:ea typeface="Calibri"/>
                 <a:cs typeface="Calibri"/>
               </a:rPr>
-              <a:t>自底向上：</a:t>
+              <a:t>每个 spec 都写清：</a:t>
             </a:r>
             <a:endParaRPr sz="900"/>
           </a:p>
@@ -9330,7 +9345,7 @@
                 <a:ea typeface="Calibri"/>
                 <a:cs typeface="Calibri"/>
               </a:rPr>
-              <a:t>① 合约层 — 接口定义</a:t>
+              <a:t>① 进入状态</a:t>
             </a:r>
             <a:endParaRPr sz="900"/>
           </a:p>
@@ -9347,7 +9362,7 @@
                 <a:ea typeface="Calibri"/>
                 <a:cs typeface="Calibri"/>
               </a:rPr>
-              <a:t>② API 路由层 — 路由绑定</a:t>
+              <a:t>② 本规格实现程度</a:t>
             </a:r>
             <a:endParaRPr sz="900"/>
           </a:p>
@@ -9364,7 +9379,7 @@
                 <a:ea typeface="Calibri"/>
                 <a:cs typeface="Calibri"/>
               </a:rPr>
-              <a:t>③ 数据层 — ORM/DB</a:t>
+              <a:t>③ 退出状态</a:t>
             </a:r>
             <a:endParaRPr sz="900"/>
           </a:p>
@@ -9381,7 +9396,7 @@
                 <a:ea typeface="Calibri"/>
                 <a:cs typeface="Calibri"/>
               </a:rPr>
-              <a:t>④ UI 层 — 前端组件</a:t>
+              <a:t>④ 临时实现与收口责任</a:t>
             </a:r>
             <a:endParaRPr sz="900"/>
           </a:p>
@@ -9389,6 +9404,9 @@
             <a:pPr marL="0" indent="0">
               <a:buNone/>
             </a:pPr>
+            <a:r>
+              <a:t/>
+            </a:r>
             <a:endParaRPr sz="900"/>
           </a:p>
           <a:p xmlns:a="http://schemas.openxmlformats.org/drawingml/2006/main">
@@ -9404,7 +9422,24 @@
                 <a:ea typeface="Calibri"/>
                 <a:cs typeface="Calibri"/>
               </a:rPr>
-              <a:t>组合各 spec 的 check.md</a:t>
+              <a:t>有向依赖 + 稳定契约</a:t>
+            </a:r>
+            <a:endParaRPr sz="900"/>
+          </a:p>
+          <a:p xmlns:a="http://schemas.openxmlformats.org/drawingml/2006/main">
+            <a:pPr marL="0" indent="0">
+              <a:buNone/>
+            </a:pPr>
+            <a:r>
+              <a:rPr sz="900">
+                <a:solidFill>
+                  <a:srgbClr val="64748B"/>
+                </a:solidFill>
+                <a:latin typeface="Calibri"/>
+                <a:ea typeface="Calibri"/>
+                <a:cs typeface="Calibri"/>
+              </a:rPr>
+              <a:t>按顺序可等价复原</a:t>
             </a:r>
             <a:endParaRPr sz="900"/>
           </a:p>
@@ -9929,7 +9964,7 @@
                 <a:ea typeface="Calibri"/>
                 <a:cs typeface="Calibri"/>
               </a:rPr>
-              <a:t>Dev 给方向，AI 写完整方案（ADR + specs）</a:t>
+              <a:t>架构写当前，ADR 只记低频决策历史</a:t>
             </a:r>
             <a:endParaRPr sz="1200"/>
           </a:p>
@@ -10053,7 +10088,7 @@
                 <a:ea typeface="Calibri"/>
                 <a:cs typeface="Calibri"/>
               </a:rPr>
-              <a:t>方案必须评审，PM 说看不懂 = 不合格</a:t>
+              <a:t>spec 写进入 / 实现 / 退出与收口责任</a:t>
             </a:r>
             <a:endParaRPr sz="1200"/>
           </a:p>
@@ -10177,7 +10212,7 @@
                 <a:ea typeface="Calibri"/>
                 <a:cs typeface="Calibri"/>
               </a:rPr>
-              <a:t>AI 按 spec 编码，不跳步骤不改方案</a:t>
+              <a:t>先评审，再按有向依赖编码并验收</a:t>
             </a:r>
             <a:endParaRPr sz="1200"/>
           </a:p>
@@ -10301,7 +10336,7 @@
                 <a:ea typeface="Calibri"/>
                 <a:cs typeface="Calibri"/>
               </a:rPr>
-              <a:t>人管边界，AI 管标准 — 互补不是替代</a:t>
+              <a:t>删除代码后，仍可按规格等价复原阶段交付</a:t>
             </a:r>
             <a:endParaRPr sz="1200"/>
           </a:p>
@@ -13149,7 +13184,7 @@
                 <a:ea typeface="Calibri"/>
                 <a:cs typeface="Calibri"/>
               </a:rPr>
-              <a:t>adrs/</a:t>
+              <a:t>architecture/</a:t>
             </a:r>
             <a:endParaRPr sz="1300"/>
           </a:p>
@@ -13195,7 +13230,24 @@
                 <a:ea typeface="Calibri"/>
                 <a:cs typeface="Calibri"/>
               </a:rPr>
-              <a:t>架构变动设计（一次大型变动一整份）</a:t>
+              <a:t>当前架构 3 文件（无 README）</a:t>
+            </a:r>
+            <a:endParaRPr sz="1000"/>
+          </a:p>
+          <a:p xmlns:a="http://schemas.openxmlformats.org/drawingml/2006/main">
+            <a:pPr marL="0" indent="0">
+              <a:buNone/>
+            </a:pPr>
+            <a:r>
+              <a:rPr sz="1000">
+                <a:solidFill>
+                  <a:srgbClr val="64748B"/>
+                </a:solidFill>
+                <a:latin typeface="Calibri"/>
+                <a:ea typeface="Calibri"/>
+                <a:cs typeface="Calibri"/>
+              </a:rPr>
+              <a:t>+ adrs/ 单文件决策历史</a:t>
             </a:r>
             <a:endParaRPr sz="1000"/>
           </a:p>
@@ -14975,7 +15027,7 @@
                 <a:ea typeface="Calibri"/>
                 <a:cs typeface="Calibri"/>
               </a:rPr>
-              <a:t>架构 + 方案 + 边界</a:t>
+              <a:t>基线 + 进入 / 实现 / 退出状态</a:t>
             </a:r>
             <a:endParaRPr sz="900"/>
           </a:p>
@@ -15099,7 +15151,7 @@
                 <a:ea typeface="Calibri"/>
                 <a:cs typeface="Calibri"/>
               </a:rPr>
-              <a:t>实现步骤 + 文件清单</a:t>
+              <a:t>可复原步骤 + 文件 / 迁移清单</a:t>
             </a:r>
             <a:endParaRPr sz="900"/>
           </a:p>
@@ -15223,7 +15275,7 @@
                 <a:ea typeface="Calibri"/>
                 <a:cs typeface="Calibri"/>
               </a:rPr>
-              <a:t>拆分 + 状态跟踪</a:t>
+              <a:t>有向依赖 + 状态跟踪</a:t>
             </a:r>
             <a:endParaRPr sz="900"/>
           </a:p>
@@ -15347,7 +15399,7 @@
                 <a:ea typeface="Calibri"/>
                 <a:cs typeface="Calibri"/>
               </a:rPr>
-              <a:t>自检 + 人工验收</a:t>
+              <a:t>阶段自检 + 人工验收</a:t>
             </a:r>
             <a:endParaRPr sz="900"/>
           </a:p>
@@ -15464,7 +15516,7 @@
                 <a:ea typeface="Calibri"/>
                 <a:cs typeface="Calibri"/>
               </a:rPr>
-              <a:t>adrs/ 架构文档库</a:t>
+              <a:t>architecture/ 当前架构</a:t>
             </a:r>
             <a:endParaRPr sz="1300"/>
           </a:p>
@@ -15510,14 +15562,7 @@
                 <a:ea typeface="Calibri"/>
                 <a:cs typeface="Calibri"/>
               </a:rPr>
-              <a:t>一次大型变动 = 一个 adr 文件夹（3 份文档）：
-architecture.md
-架构总览（上下文/组件/技术选型）
-data-model.md
-数据模型（实体/表结构）
-impact.md
-影响与注意事项
-整个系统的技术设计只出现在 adrs/</a:t>
+              <a:t>根目录最多 3 份文档（无 README）：</a:t>
             </a:r>
             <a:endParaRPr sz="1000"/>
           </a:p>
@@ -15525,6 +15570,9 @@
             <a:pPr marL="0" indent="0">
               <a:buNone/>
             </a:pPr>
+            <a:r>
+              <a:t/>
+            </a:r>
             <a:endParaRPr sz="1000"/>
           </a:p>
           <a:p xmlns:a="http://schemas.openxmlformats.org/drawingml/2006/main">
@@ -15540,6 +15588,32 @@
                 <a:ea typeface="Calibri"/>
                 <a:cs typeface="Calibri"/>
               </a:rPr>
+              <a:t>architecture.md</a:t>
+            </a:r>
+            <a:endParaRPr sz="1000"/>
+          </a:p>
+          <a:p xmlns:a="http://schemas.openxmlformats.org/drawingml/2006/main">
+            <a:pPr marL="0" indent="0">
+              <a:buNone/>
+            </a:pPr>
+            <a:r>
+              <a:rPr sz="900">
+                <a:solidFill>
+                  <a:srgbClr val="64748B"/>
+                </a:solidFill>
+                <a:latin typeface="Calibri"/>
+                <a:ea typeface="Calibri"/>
+                <a:cs typeface="Calibri"/>
+              </a:rPr>
+              <a:t>代码服务 / 模块 / 边界</a:t>
+            </a:r>
+            <a:endParaRPr sz="1000"/>
+          </a:p>
+          <a:p xmlns:a="http://schemas.openxmlformats.org/drawingml/2006/main">
+            <a:pPr marL="0" indent="0">
+              <a:buNone/>
+            </a:pPr>
+            <a:r>
               <a:t/>
             </a:r>
             <a:endParaRPr sz="1000"/>
@@ -15549,6 +15623,23 @@
               <a:buNone/>
             </a:pPr>
             <a:r>
+              <a:rPr sz="1000">
+                <a:solidFill>
+                  <a:srgbClr val="1E293B"/>
+                </a:solidFill>
+                <a:latin typeface="Calibri"/>
+                <a:ea typeface="Calibri"/>
+                <a:cs typeface="Calibri"/>
+              </a:rPr>
+              <a:t>data-model.md</a:t>
+            </a:r>
+            <a:endParaRPr sz="1000"/>
+          </a:p>
+          <a:p xmlns:a="http://schemas.openxmlformats.org/drawingml/2006/main">
+            <a:pPr marL="0" indent="0">
+              <a:buNone/>
+            </a:pPr>
+            <a:r>
               <a:rPr sz="900">
                 <a:solidFill>
                   <a:srgbClr val="64748B"/>
@@ -15557,6 +15648,15 @@
                 <a:ea typeface="Calibri"/>
                 <a:cs typeface="Calibri"/>
               </a:rPr>
+              <a:t>实体 / 关系 / 数据归属</a:t>
+            </a:r>
+            <a:endParaRPr sz="1000"/>
+          </a:p>
+          <a:p xmlns:a="http://schemas.openxmlformats.org/drawingml/2006/main">
+            <a:pPr marL="0" indent="0">
+              <a:buNone/>
+            </a:pPr>
+            <a:r>
               <a:t/>
             </a:r>
             <a:endParaRPr sz="1000"/>
@@ -15565,6 +15665,17 @@
             <a:pPr marL="0" indent="0">
               <a:buNone/>
             </a:pPr>
+            <a:r>
+              <a:rPr sz="1000">
+                <a:solidFill>
+                  <a:srgbClr val="1E293B"/>
+                </a:solidFill>
+                <a:latin typeface="Calibri"/>
+                <a:ea typeface="Calibri"/>
+                <a:cs typeface="Calibri"/>
+              </a:rPr>
+              <a:t>runtime.md</a:t>
+            </a:r>
             <a:endParaRPr sz="1000"/>
           </a:p>
           <a:p xmlns:a="http://schemas.openxmlformats.org/drawingml/2006/main">
@@ -15572,14 +15683,23 @@
               <a:buNone/>
             </a:pPr>
             <a:r>
-              <a:rPr sz="1000">
-                <a:solidFill>
-                  <a:srgbClr val="1E293B"/>
-                </a:solidFill>
-                <a:latin typeface="Calibri"/>
-                <a:ea typeface="Calibri"/>
-                <a:cs typeface="Calibri"/>
-              </a:rPr>
+              <a:rPr sz="900">
+                <a:solidFill>
+                  <a:srgbClr val="64748B"/>
+                </a:solidFill>
+                <a:latin typeface="Calibri"/>
+                <a:ea typeface="Calibri"/>
+                <a:cs typeface="Calibri"/>
+              </a:rPr>
+              <a:t>中间件 / 外部服务 / 部署形态</a:t>
+            </a:r>
+            <a:endParaRPr sz="1000"/>
+          </a:p>
+          <a:p xmlns:a="http://schemas.openxmlformats.org/drawingml/2006/main">
+            <a:pPr marL="0" indent="0">
+              <a:buNone/>
+            </a:pPr>
+            <a:r>
               <a:t/>
             </a:r>
             <a:endParaRPr sz="1000"/>
@@ -15589,7 +15709,7 @@
               <a:buNone/>
             </a:pPr>
             <a:r>
-              <a:rPr sz="900">
+              <a:rPr sz="900" b="1">
                 <a:solidFill>
                   <a:srgbClr val="64748B"/>
                 </a:solidFill>
@@ -15597,7 +15717,7 @@
                 <a:ea typeface="Calibri"/>
                 <a:cs typeface="Calibri"/>
               </a:rPr>
-              <a:t/>
+              <a:t>architecture/adrs/</a:t>
             </a:r>
             <a:endParaRPr sz="1000"/>
           </a:p>
@@ -15605,31 +15725,8 @@
             <a:pPr marL="0" indent="0">
               <a:buNone/>
             </a:pPr>
-            <a:endParaRPr sz="1000"/>
-          </a:p>
-          <a:p xmlns:a="http://schemas.openxmlformats.org/drawingml/2006/main">
-            <a:pPr marL="0" indent="0">
-              <a:buNone/>
-            </a:pPr>
-            <a:r>
-              <a:rPr sz="1000">
-                <a:solidFill>
-                  <a:srgbClr val="1E293B"/>
-                </a:solidFill>
-                <a:latin typeface="Calibri"/>
-                <a:ea typeface="Calibri"/>
-                <a:cs typeface="Calibri"/>
-              </a:rPr>
-              <a:t/>
-            </a:r>
-            <a:endParaRPr sz="1000"/>
-          </a:p>
-          <a:p xmlns:a="http://schemas.openxmlformats.org/drawingml/2006/main">
-            <a:pPr marL="0" indent="0">
-              <a:buNone/>
-            </a:pPr>
-            <a:r>
-              <a:rPr sz="900">
+            <a:r>
+              <a:rPr sz="900" b="1">
                 <a:solidFill>
                   <a:srgbClr val="64748B"/>
                 </a:solidFill>
@@ -15637,30 +15734,7 @@
                 <a:ea typeface="Calibri"/>
                 <a:cs typeface="Calibri"/>
               </a:rPr>
-              <a:t/>
-            </a:r>
-            <a:endParaRPr sz="1000"/>
-          </a:p>
-          <a:p xmlns:a="http://schemas.openxmlformats.org/drawingml/2006/main">
-            <a:pPr marL="0" indent="0">
-              <a:buNone/>
-            </a:pPr>
-            <a:endParaRPr sz="1000"/>
-          </a:p>
-          <a:p xmlns:a="http://schemas.openxmlformats.org/drawingml/2006/main">
-            <a:pPr marL="0" indent="0">
-              <a:buNone/>
-            </a:pPr>
-            <a:r>
-              <a:rPr sz="900" b="1">
-                <a:solidFill>
-                  <a:srgbClr val="64748B"/>
-                </a:solidFill>
-                <a:latin typeface="Calibri"/>
-                <a:ea typeface="Calibri"/>
-                <a:cs typeface="Calibri"/>
-              </a:rPr>
-              <a:t/>
+              <a:t>低频、不可变的单文件 ADR 历史</a:t>
             </a:r>
             <a:endParaRPr sz="1000"/>
           </a:p>
@@ -16309,7 +16383,7 @@
                 <a:ea typeface="Calibri"/>
                 <a:cs typeface="Calibri"/>
               </a:rPr>
-              <a:t>adrs/（一次大变动一个文件夹）+ specs/</a:t>
+              <a:t>当前架构 + 必要 ADR + specs/</a:t>
             </a:r>
             <a:endParaRPr sz="900"/>
           </a:p>
@@ -17052,7 +17126,7 @@
                 <a:ea typeface="Calibri"/>
                 <a:cs typeface="Calibri"/>
               </a:rPr>
-              <a:t>Step 2: Dev 给方向 → AI 写方案</a:t>
+              <a:t>Step 2: Dev 定阶段边界 → AI 写规格与必要架构决策</a:t>
             </a:r>
             <a:endParaRPr sz="1000"/>
           </a:p>
@@ -17086,7 +17160,7 @@
                 <a:ea typeface="Calibri"/>
                 <a:cs typeface="Calibri"/>
               </a:rPr>
-              <a:t>Step 4: AI 按 spec 实现 → 自检 → 等待确认</a:t>
+              <a:t>Step 4: AI 按依赖顺序实现 → 自检 → 等待确认</a:t>
             </a:r>
             <a:endParaRPr sz="1000"/>
           </a:p>
@@ -17103,7 +17177,7 @@
                 <a:ea typeface="Calibri"/>
                 <a:cs typeface="Calibri"/>
               </a:rPr>
-              <a:t>Step 5: Dev 修复边界 + QA 验收</a:t>
+              <a:t>Step 5: Dev 收口临时边界 + QA 验收</a:t>
             </a:r>
             <a:endParaRPr sz="1000"/>
           </a:p>
@@ -18416,10 +18490,7 @@
                 <a:ea typeface="Calibri"/>
                 <a:cs typeface="Calibri"/>
               </a:rPr>
-              <a:t>① 本次迭代拆几个 spec？
-② 是大型架构变动吗？（是→一个 adr 文件夹）
-③ 跨 spec 依赖？
-④ 核心 API/表名？</a:t>
+              <a:t>① spec 边界与依赖方向？</a:t>
             </a:r>
             <a:endParaRPr sz="1000"/>
           </a:p>
@@ -18436,7 +18507,7 @@
                 <a:ea typeface="Calibri"/>
                 <a:cs typeface="Calibri"/>
               </a:rPr>
-              <a:t/>
+              <a:t>② 是否改变架构不变量？</a:t>
             </a:r>
             <a:endParaRPr sz="1000"/>
           </a:p>
@@ -18453,7 +18524,7 @@
                 <a:ea typeface="Calibri"/>
                 <a:cs typeface="Calibri"/>
               </a:rPr>
-              <a:t/>
+              <a:t>③ 进入 / 实现程度 / 退出状态？</a:t>
             </a:r>
             <a:endParaRPr sz="1000"/>
           </a:p>
@@ -18470,7 +18541,7 @@
                 <a:ea typeface="Calibri"/>
                 <a:cs typeface="Calibri"/>
               </a:rPr>
-              <a:t/>
+              <a:t>④ Mock / 占位由哪个 spec 收口？</a:t>
             </a:r>
             <a:endParaRPr sz="1000"/>
           </a:p>
@@ -18633,7 +18704,7 @@
                 <a:ea typeface="Calibri"/>
                 <a:cs typeface="Calibri"/>
               </a:rPr>
-              <a:t>→ adrs/ 架构文档 + 迭代 specs/ 四文件</a:t>
+              <a:t>→ architecture/ 当前架构（最多 3 文件）</a:t>
             </a:r>
             <a:endParaRPr sz="1000"/>
           </a:p>
@@ -18650,7 +18721,7 @@
                 <a:ea typeface="Calibri"/>
                 <a:cs typeface="Calibri"/>
               </a:rPr>
-              <a:t>→ requirements.md</a:t>
+              <a:t>→ 必要时新增单文件 ADR</a:t>
             </a:r>
             <a:endParaRPr sz="1000"/>
           </a:p>
@@ -18667,7 +18738,7 @@
                 <a:ea typeface="Calibri"/>
                 <a:cs typeface="Calibri"/>
               </a:rPr>
-              <a:t>→ plan.md</a:t>
+              <a:t>→ specs/ 四文件</a:t>
             </a:r>
             <a:endParaRPr sz="1000"/>
           </a:p>
@@ -18684,7 +18755,7 @@
                 <a:ea typeface="Calibri"/>
                 <a:cs typeface="Calibri"/>
               </a:rPr>
-              <a:t>→ tasks.md</a:t>
+              <a:t>→ requirements：阶段边界</a:t>
             </a:r>
             <a:endParaRPr sz="1000"/>
           </a:p>
@@ -18701,7 +18772,7 @@
                 <a:ea typeface="Calibri"/>
                 <a:cs typeface="Calibri"/>
               </a:rPr>
-              <a:t>→ check.md</a:t>
+              <a:t>→ plan / tasks / check：实现与验收</a:t>
             </a:r>
             <a:endParaRPr sz="1000"/>
           </a:p>

</xml_diff>

<commit_message>
feat: strengthen adaptive contract governance
</commit_message>
<xml_diff>
--- a/SSOT-开发方法论-培训.pptx
+++ b/SSOT-开发方法论-培训.pptx
@@ -2,28 +2,28 @@
 <file path=ppt/presentation.xml><?xml version="1.0" encoding="utf-8"?>
 <p:presentation xmlns:p="http://schemas.openxmlformats.org/presentationml/2006/main">
   <p:sldMasterIdLst>
-    <p:sldMasterId xmlns:r="http://schemas.openxmlformats.org/officeDocument/2006/relationships" id="2147483648" r:id="R44ec0fa5e3db4861"/>
+    <p:sldMasterId xmlns:r="http://schemas.openxmlformats.org/officeDocument/2006/relationships" id="2147483648" r:id="R8c6ec3af9b2e4b2c"/>
   </p:sldMasterIdLst>
   <p:notesMasterIdLst>
-    <p:notesMasterId xmlns:r="http://schemas.openxmlformats.org/officeDocument/2006/relationships" r:id="R1c45c2b325e64d46"/>
+    <p:notesMasterId xmlns:r="http://schemas.openxmlformats.org/officeDocument/2006/relationships" r:id="R7ec0b9b29aa94887"/>
   </p:notesMasterIdLst>
   <p:sldIdLst>
-    <p:sldId xmlns:r="http://schemas.openxmlformats.org/officeDocument/2006/relationships" id="256" r:id="R0633c926d66b42ca"/>
-    <p:sldId xmlns:r="http://schemas.openxmlformats.org/officeDocument/2006/relationships" id="257" r:id="Rc975d4dfab7340df"/>
-    <p:sldId xmlns:r="http://schemas.openxmlformats.org/officeDocument/2006/relationships" id="258" r:id="R411ef13384cb451d"/>
-    <p:sldId xmlns:r="http://schemas.openxmlformats.org/officeDocument/2006/relationships" id="259" r:id="R0f79f9e2db074c4d"/>
-    <p:sldId xmlns:r="http://schemas.openxmlformats.org/officeDocument/2006/relationships" id="260" r:id="R9e12ad46df164046"/>
-    <p:sldId xmlns:r="http://schemas.openxmlformats.org/officeDocument/2006/relationships" id="261" r:id="Rc2ffe51397914131"/>
-    <p:sldId xmlns:r="http://schemas.openxmlformats.org/officeDocument/2006/relationships" id="262" r:id="R364dfe2bd6794924"/>
-    <p:sldId xmlns:r="http://schemas.openxmlformats.org/officeDocument/2006/relationships" id="263" r:id="R8bd7cf3f3c524aef"/>
-    <p:sldId xmlns:r="http://schemas.openxmlformats.org/officeDocument/2006/relationships" id="264" r:id="Rea97e6e9f2ed49be"/>
-    <p:sldId xmlns:r="http://schemas.openxmlformats.org/officeDocument/2006/relationships" id="265" r:id="Rc11aff910555483d"/>
-    <p:sldId xmlns:r="http://schemas.openxmlformats.org/officeDocument/2006/relationships" id="266" r:id="Rad14ec04a10943ee"/>
-    <p:sldId xmlns:r="http://schemas.openxmlformats.org/officeDocument/2006/relationships" id="267" r:id="Rcc91b38925e14700"/>
-    <p:sldId xmlns:r="http://schemas.openxmlformats.org/officeDocument/2006/relationships" id="268" r:id="Ra2af81c4ace04145"/>
-    <p:sldId xmlns:r="http://schemas.openxmlformats.org/officeDocument/2006/relationships" id="269" r:id="Rb0198d7dcc43425a"/>
-    <p:sldId xmlns:r="http://schemas.openxmlformats.org/officeDocument/2006/relationships" id="270" r:id="R2fb5c153b87447c6"/>
-    <p:sldId xmlns:r="http://schemas.openxmlformats.org/officeDocument/2006/relationships" id="271" r:id="Rb9223c65f1304df5"/>
+    <p:sldId xmlns:r="http://schemas.openxmlformats.org/officeDocument/2006/relationships" id="256" r:id="Radaec883412e4b20"/>
+    <p:sldId xmlns:r="http://schemas.openxmlformats.org/officeDocument/2006/relationships" id="257" r:id="R5a0987a4a1194f21"/>
+    <p:sldId xmlns:r="http://schemas.openxmlformats.org/officeDocument/2006/relationships" id="258" r:id="Rbc3b85ab4ca34188"/>
+    <p:sldId xmlns:r="http://schemas.openxmlformats.org/officeDocument/2006/relationships" id="259" r:id="Rbbb829e5c2f24e34"/>
+    <p:sldId xmlns:r="http://schemas.openxmlformats.org/officeDocument/2006/relationships" id="260" r:id="R86a9e4ac5992432c"/>
+    <p:sldId xmlns:r="http://schemas.openxmlformats.org/officeDocument/2006/relationships" id="261" r:id="Rd9e107fe5dec45d6"/>
+    <p:sldId xmlns:r="http://schemas.openxmlformats.org/officeDocument/2006/relationships" id="262" r:id="R76e871391c6d4a32"/>
+    <p:sldId xmlns:r="http://schemas.openxmlformats.org/officeDocument/2006/relationships" id="263" r:id="R541383bc309a4dab"/>
+    <p:sldId xmlns:r="http://schemas.openxmlformats.org/officeDocument/2006/relationships" id="264" r:id="R90fba8b6a1934394"/>
+    <p:sldId xmlns:r="http://schemas.openxmlformats.org/officeDocument/2006/relationships" id="265" r:id="Rcf3371da901a4134"/>
+    <p:sldId xmlns:r="http://schemas.openxmlformats.org/officeDocument/2006/relationships" id="266" r:id="R3c026c83be394bc5"/>
+    <p:sldId xmlns:r="http://schemas.openxmlformats.org/officeDocument/2006/relationships" id="267" r:id="Rc140b623b33c41f5"/>
+    <p:sldId xmlns:r="http://schemas.openxmlformats.org/officeDocument/2006/relationships" id="268" r:id="R0c67fa96a44f4792"/>
+    <p:sldId xmlns:r="http://schemas.openxmlformats.org/officeDocument/2006/relationships" id="269" r:id="Rf1f609215ac94b22"/>
+    <p:sldId xmlns:r="http://schemas.openxmlformats.org/officeDocument/2006/relationships" id="270" r:id="Ra2f780905aa949d7"/>
+    <p:sldId xmlns:r="http://schemas.openxmlformats.org/officeDocument/2006/relationships" id="271" r:id="R4f05a4c0cccf4dec"/>
   </p:sldIdLst>
   <p:sldSz cx="9144000" cy="5143500"/>
   <p:notesSz cx="6858000" cy="9144000"/>
@@ -1631,7 +1631,7 @@
   </p:cSld>
   <p:clrMap bg1="lt1" tx1="dk1" bg2="lt2" tx2="dk2" accent1="accent1" accent2="accent2" accent3="accent3" accent4="accent4" accent5="accent5" accent6="accent6" hlink="hlink" folHlink="folHlink"/>
   <p:sldLayoutIdLst>
-    <p:sldLayoutId xmlns:r="http://schemas.openxmlformats.org/officeDocument/2006/relationships" id="2147483649" r:id="R6b957e759eef4d8e"/>
+    <p:sldLayoutId xmlns:r="http://schemas.openxmlformats.org/officeDocument/2006/relationships" id="2147483649" r:id="Rb91c7885fed045ea"/>
   </p:sldLayoutIdLst>
   <p:hf sldNum="0" hdr="0" ftr="0" dt="0"/>
   <p:txStyles>
@@ -5242,7 +5242,7 @@
           <p:cNvPr id="19" name="Table 0">
             <a:extLst xmlns:a="http://schemas.openxmlformats.org/drawingml/2006/main">
               <a:ext uri="{FF2B5EF4-FFF2-40B4-BE49-F238E27FC236}">
-                <a16:creationId xmlns:a16="http://schemas.microsoft.com/office/drawing/2014/main" id="{0E2A0980-899E-40A2-A3A1-BDC8A1C0E48F}"/>
+                <a16:creationId xmlns:a16="http://schemas.microsoft.com/office/drawing/2014/main" id="{DDF01C6B-0DDB-46B8-97E6-A598FB1A26E3}"/>
               </a:ext>
             </a:extLst>
           </p:cNvPr>
@@ -6978,7 +6978,7 @@
                 <a:ea typeface="Calibri"/>
                 <a:cs typeface="Calibri"/>
               </a:rPr>
-              <a:t>核心: 当前架构、架构决策、阶段边界</a:t>
+              <a:t>核心: 当前架构、契约语义、阶段边界</a:t>
             </a:r>
             <a:endParaRPr sz="900"/>
           </a:p>
@@ -7701,7 +7701,7 @@
                 <a:ea typeface="Calibri"/>
                 <a:cs typeface="Calibri"/>
               </a:rPr>
-              <a:t>部署 / 配置 / 接口 / 手册</a:t>
+              <a:t>部署 / 配置 / 契约发布 / 手册</a:t>
             </a:r>
             <a:endParaRPr sz="900"/>
           </a:p>
@@ -8847,7 +8847,7 @@
                 <a:ea typeface="Calibri"/>
                 <a:cs typeface="Calibri"/>
               </a:rPr>
-              <a:t>跨模块协作</a:t>
+              <a:t>契约治理</a:t>
             </a:r>
             <a:endParaRPr sz="1300"/>
           </a:p>
@@ -8925,7 +8925,7 @@
                 <a:ea typeface="Calibri"/>
                 <a:cs typeface="Calibri"/>
               </a:rPr>
-              <a:t>当 spec 依赖其他 spec 时，使用 Context Contract（≤15 行）</a:t>
+              <a:t>AI 先识别协作边界；共享边界先定权威契约，再进入并行开发</a:t>
             </a:r>
             <a:endParaRPr sz="1100"/>
           </a:p>
@@ -9042,7 +9042,7 @@
                 <a:ea typeface="Calibri"/>
                 <a:cs typeface="Calibri"/>
               </a:rPr>
-              <a:t>Context Contract</a:t>
+              <a:t>共享边界契约</a:t>
             </a:r>
             <a:endParaRPr sz="1100"/>
           </a:p>
@@ -9088,7 +9088,7 @@
                 <a:ea typeface="Calibri"/>
                 <a:cs typeface="Calibri"/>
               </a:rPr>
-              <a:t>## Context from Dependencies</a:t>
+              <a:t>适用边界</a:t>
             </a:r>
             <a:endParaRPr sz="900"/>
           </a:p>
@@ -9097,14 +9097,26 @@
               <a:buNone/>
             </a:pPr>
             <a:r>
-              <a:t/>
-            </a:r>
-            <a:endParaRPr sz="900"/>
+              <a:rPr sz="900" b="1">
+                <a:solidFill>
+                  <a:srgbClr val="1E293B"/>
+                </a:solidFill>
+                <a:latin typeface="Calibri"/>
+                <a:ea typeface="Calibri"/>
+                <a:cs typeface="Calibri"/>
+              </a:rPr>
+              <a:t>跨服务 / 进程 / 语言 / 独立部署 / 外部消费者</a:t>
+            </a:r>
           </a:p>
           <a:p xmlns:a="http://schemas.openxmlformats.org/drawingml/2006/main">
             <a:pPr marL="0" indent="0">
               <a:buNone/>
             </a:pPr>
+          </a:p>
+          <a:p xmlns:a="http://schemas.openxmlformats.org/drawingml/2006/main">
+            <a:pPr marL="0" indent="0">
+              <a:buNone/>
+            </a:pPr>
             <a:r>
               <a:rPr sz="900" b="1">
                 <a:solidFill>
@@ -9114,16 +9126,15 @@
                 <a:ea typeface="Calibri"/>
                 <a:cs typeface="Calibri"/>
               </a:rPr>
-              <a:t>### spec-002 → spec-004</a:t>
-            </a:r>
-            <a:endParaRPr sz="900"/>
+              <a:t>生产方负责契约语义</a:t>
+            </a:r>
           </a:p>
           <a:p xmlns:a="http://schemas.openxmlformats.org/drawingml/2006/main">
             <a:pPr marL="0" indent="0">
               <a:buNone/>
             </a:pPr>
             <a:r>
-              <a:rPr sz="900">
+              <a:rPr sz="900" b="1">
                 <a:solidFill>
                   <a:srgbClr val="1E293B"/>
                 </a:solidFill>
@@ -9131,16 +9142,15 @@
                 <a:ea typeface="Calibri"/>
                 <a:cs typeface="Calibri"/>
               </a:rPr>
-              <a:t>- POST /api/auth/login</a:t>
-            </a:r>
-            <a:endParaRPr sz="900"/>
+              <a:t>消费方参与依赖评审</a:t>
+            </a:r>
           </a:p>
           <a:p xmlns:a="http://schemas.openxmlformats.org/drawingml/2006/main">
             <a:pPr marL="0" indent="0">
               <a:buNone/>
             </a:pPr>
             <a:r>
-              <a:rPr sz="900">
+              <a:rPr sz="900" b="1">
                 <a:solidFill>
                   <a:srgbClr val="1E293B"/>
                 </a:solidFill>
@@ -9148,16 +9158,15 @@
                 <a:ea typeface="Calibri"/>
                 <a:cs typeface="Calibri"/>
               </a:rPr>
-              <a:t>- owner: spec-004</a:t>
-            </a:r>
-            <a:endParaRPr sz="900"/>
+              <a:t>assets/interfaces/ 是唯一当前契约</a:t>
+            </a:r>
           </a:p>
           <a:p xmlns:a="http://schemas.openxmlformats.org/drawingml/2006/main">
             <a:pPr marL="0" indent="0">
               <a:buNone/>
             </a:pPr>
             <a:r>
-              <a:rPr sz="900">
+              <a:rPr sz="900" b="1">
                 <a:solidFill>
                   <a:srgbClr val="1E293B"/>
                 </a:solidFill>
@@ -9165,9 +9174,8 @@
                 <a:ea typeface="Calibri"/>
                 <a:cs typeface="Calibri"/>
               </a:rPr>
-              <a:t>- Mock = 正式契约</a:t>
-            </a:r>
-            <a:endParaRPr sz="900"/>
+              <a:t>Context Contract 只作为执行摘要</a:t>
+            </a:r>
           </a:p>
         </p:txBody>
       </p:sp>
@@ -9282,7 +9290,7 @@
                 <a:ea typeface="Calibri"/>
                 <a:cs typeface="Calibri"/>
               </a:rPr>
-              <a:t>阶段收口检查</a:t>
+              <a:t>工具由用户决定</a:t>
             </a:r>
             <a:endParaRPr sz="1100"/>
           </a:p>
@@ -9328,7 +9336,7 @@
                 <a:ea typeface="Calibri"/>
                 <a:cs typeface="Calibri"/>
               </a:rPr>
-              <a:t>每个 spec 都写清：</a:t>
+              <a:t>无共享边界</a:t>
             </a:r>
             <a:endParaRPr sz="900"/>
           </a:p>
@@ -9337,7 +9345,7 @@
               <a:buNone/>
             </a:pPr>
             <a:r>
-              <a:rPr sz="900">
+              <a:rPr sz="900" b="1">
                 <a:solidFill>
                   <a:srgbClr val="1E293B"/>
                 </a:solidFill>
@@ -9345,16 +9353,20 @@
                 <a:ea typeface="Calibri"/>
                 <a:cs typeface="Calibri"/>
               </a:rPr>
-              <a:t>① 进入状态</a:t>
-            </a:r>
-            <a:endParaRPr sz="900"/>
+              <a:t>不额外创建公共契约</a:t>
+            </a:r>
           </a:p>
           <a:p xmlns:a="http://schemas.openxmlformats.org/drawingml/2006/main">
             <a:pPr marL="0" indent="0">
               <a:buNone/>
             </a:pPr>
-            <a:r>
-              <a:rPr sz="900">
+          </a:p>
+          <a:p xmlns:a="http://schemas.openxmlformats.org/drawingml/2006/main">
+            <a:pPr marL="0" indent="0">
+              <a:buNone/>
+            </a:pPr>
+            <a:r>
+              <a:rPr sz="900" b="1">
                 <a:solidFill>
                   <a:srgbClr val="1E293B"/>
                 </a:solidFill>
@@ -9362,16 +9374,15 @@
                 <a:ea typeface="Calibri"/>
                 <a:cs typeface="Calibri"/>
               </a:rPr>
-              <a:t>② 本规格实现程度</a:t>
-            </a:r>
-            <a:endParaRPr sz="900"/>
+              <a:t>可选工具</a:t>
+            </a:r>
           </a:p>
           <a:p xmlns:a="http://schemas.openxmlformats.org/drawingml/2006/main">
             <a:pPr marL="0" indent="0">
               <a:buNone/>
             </a:pPr>
             <a:r>
-              <a:rPr sz="900">
+              <a:rPr sz="900" b="1">
                 <a:solidFill>
                   <a:srgbClr val="1E293B"/>
                 </a:solidFill>
@@ -9379,16 +9390,15 @@
                 <a:ea typeface="Calibri"/>
                 <a:cs typeface="Calibri"/>
               </a:rPr>
-              <a:t>③ 退出状态</a:t>
-            </a:r>
-            <a:endParaRPr sz="900"/>
+              <a:t>契约检查 / 生成 / Mock</a:t>
+            </a:r>
           </a:p>
           <a:p xmlns:a="http://schemas.openxmlformats.org/drawingml/2006/main">
             <a:pPr marL="0" indent="0">
               <a:buNone/>
             </a:pPr>
             <a:r>
-              <a:rPr sz="900">
+              <a:rPr sz="900" b="1">
                 <a:solidFill>
                   <a:srgbClr val="1E293B"/>
                 </a:solidFill>
@@ -9396,52 +9406,61 @@
                 <a:ea typeface="Calibri"/>
                 <a:cs typeface="Calibri"/>
               </a:rPr>
-              <a:t>④ 临时实现与收口责任</a:t>
-            </a:r>
-            <a:endParaRPr sz="900"/>
+              <a:t>模型检查 / 可视化</a:t>
+            </a:r>
           </a:p>
           <a:p xmlns:a="http://schemas.openxmlformats.org/drawingml/2006/main">
             <a:pPr marL="0" indent="0">
               <a:buNone/>
             </a:pPr>
-            <a:r>
-              <a:t/>
-            </a:r>
-            <a:endParaRPr sz="900"/>
           </a:p>
           <a:p xmlns:a="http://schemas.openxmlformats.org/drawingml/2006/main">
             <a:pPr marL="0" indent="0">
               <a:buNone/>
             </a:pPr>
             <a:r>
-              <a:rPr sz="900">
-                <a:solidFill>
-                  <a:srgbClr val="64748B"/>
-                </a:solidFill>
-                <a:latin typeface="Calibri"/>
-                <a:ea typeface="Calibri"/>
-                <a:cs typeface="Calibri"/>
-              </a:rPr>
-              <a:t>有向依赖 + 稳定契约</a:t>
-            </a:r>
-            <a:endParaRPr sz="900"/>
+              <a:rPr sz="900" b="1">
+                <a:solidFill>
+                  <a:srgbClr val="1E293B"/>
+                </a:solidFill>
+                <a:latin typeface="Calibri"/>
+                <a:ea typeface="Calibri"/>
+                <a:cs typeface="Calibri"/>
+              </a:rPr>
+              <a:t>用户确认后另建 spec</a:t>
+            </a:r>
           </a:p>
           <a:p xmlns:a="http://schemas.openxmlformats.org/drawingml/2006/main">
             <a:pPr marL="0" indent="0">
               <a:buNone/>
             </a:pPr>
             <a:r>
-              <a:rPr sz="900">
-                <a:solidFill>
-                  <a:srgbClr val="64748B"/>
-                </a:solidFill>
-                <a:latin typeface="Calibri"/>
-                <a:ea typeface="Calibri"/>
-                <a:cs typeface="Calibri"/>
-              </a:rPr>
-              <a:t>按顺序可等价复原</a:t>
-            </a:r>
-            <a:endParaRPr sz="900"/>
+              <a:rPr sz="900" b="1">
+                <a:solidFill>
+                  <a:srgbClr val="1E293B"/>
+                </a:solidFill>
+                <a:latin typeface="Calibri"/>
+                <a:ea typeface="Calibri"/>
+                <a:cs typeface="Calibri"/>
+              </a:rPr>
+              <a:t>在 tools/ 中正常推进</a:t>
+            </a:r>
+          </a:p>
+          <a:p xmlns:a="http://schemas.openxmlformats.org/drawingml/2006/main">
+            <a:pPr marL="0" indent="0">
+              <a:buNone/>
+            </a:pPr>
+            <a:r>
+              <a:rPr sz="900" b="1">
+                <a:solidFill>
+                  <a:srgbClr val="1E293B"/>
+                </a:solidFill>
+                <a:latin typeface="Calibri"/>
+                <a:ea typeface="Calibri"/>
+                <a:cs typeface="Calibri"/>
+              </a:rPr>
+              <a:t>破坏性变更回 Step 2/3</a:t>
+            </a:r>
           </a:p>
         </p:txBody>
       </p:sp>

</xml_diff>